<commit_message>
Section 10.7-10.12: rename "Wilcoxon p" -> "Mann-Whitney U p" in subtitles
Rename the p-value label on all six eGFR-ratio-by-category density
plots (Age >= 70 / 75 / 80, BMI >= 25 / 30, Sex) from
"Wilcoxon p = X" to "Mann-Whitney U p = X" -- the more familiar
name in medical literature. The underlying wilcox.test() call and
p-value are identical (Mann-Whitney U and Wilcoxon rank-sum are the
same test, different names); only the display string changes. The
Section 10.7-10.12 intro paragraph is also updated to say
"Mann-Whitney U (equivalent to Wilcoxon rank-sum)".

Table 1 (Section 2) still says "Wilcoxon rank-sum" because that is
the label produced by gtsummary::add_p() itself, and matching what
the reader sees in the actual table.

Co-Authored-By: Claude Opus 4.6 (1M context) <noreply@anthropic.com>
</commit_message>
<xml_diff>
--- a/docs/pptx/whole/jx-ratio-by-age70.pptx
+++ b/docs/pptx/whole/jx-ratio-by-age70.pptx
@@ -13100,7 +13100,7 @@
           <p:spPr>
             <a:xfrm>
               <a:off x="951755" y="1923572"/>
-              <a:ext cx="4985674" cy="82021"/>
+              <a:ext cx="5373014" cy="82021"/>
             </a:xfrm>
             <a:prstGeom prst="rect">
               <a:avLst/>
@@ -13132,7 +13132,7 @@
                   <a:latin typeface="Helvetica"/>
                   <a:cs typeface="Helvetica"/>
                 </a:rPr>
-                <a:t>Age &gt;= 70: N = 340, median = 1.06   |   Age &lt; 70: N = 603, median = 0.97   |   Wilcoxon p = &lt;0.001</a:t>
+                <a:t>Age &gt;= 70: N = 340, median = 1.06   |   Age &lt; 70: N = 603, median = 0.97   |   Mann-Whitney U p = &lt;0.001</a:t>
               </a:r>
             </a:p>
           </p:txBody>

</xml_diff>